<commit_message>
docs: clarify poster service concept and intent
</commit_message>
<xml_diff>
--- a/outputs/service-introduction-poster-a3-editable.pptx
+++ b/outputs/service-introduction-poster-a3-editable.pptx
@@ -2,13 +2,13 @@
 <file path=ppt/presentation.xml><?xml version="1.0" encoding="utf-8"?>
 <p:presentation xmlns:p="http://schemas.openxmlformats.org/presentationml/2006/main">
   <p:sldMasterIdLst>
-    <p:sldMasterId xmlns:r="http://schemas.openxmlformats.org/officeDocument/2006/relationships" id="2147483648" r:id="R2deaf776cca64c2b"/>
+    <p:sldMasterId xmlns:r="http://schemas.openxmlformats.org/officeDocument/2006/relationships" id="2147483648" r:id="Ra5e563fec74b48f7"/>
   </p:sldMasterIdLst>
   <p:notesMasterIdLst>
-    <p:notesMasterId xmlns:r="http://schemas.openxmlformats.org/officeDocument/2006/relationships" r:id="R941a7d65d4ca497e"/>
+    <p:notesMasterId xmlns:r="http://schemas.openxmlformats.org/officeDocument/2006/relationships" r:id="Rf180b0371b1f4074"/>
   </p:notesMasterIdLst>
   <p:sldIdLst>
-    <p:sldId xmlns:r="http://schemas.openxmlformats.org/officeDocument/2006/relationships" id="256" r:id="Rf9d8144a1e404791"/>
+    <p:sldId xmlns:r="http://schemas.openxmlformats.org/officeDocument/2006/relationships" id="256" r:id="R02c79029770f4e4d"/>
   </p:sldIdLst>
   <p:sldSz cx="10696575" cy="15116175"/>
   <p:notesSz cx="6858000" cy="9144000"/>
@@ -447,6 +447,21 @@
           </a:p>
           <a:p xmlns:a="http://schemas.openxmlformats.org/drawingml/2006/main">
             <a:r>
+              <a:t>- https://github.com/pkchanghyun-pixel/hub/wiki/프로젝트-기획서-[자취생-요리-추천-웹페이지-서비스]</a:t>
+            </a:r>
+          </a:p>
+          <a:p xmlns:a="http://schemas.openxmlformats.org/drawingml/2006/main">
+            <a:r>
+              <a:t>- https://github.com/pkchanghyun-pixel/hub/blob/N091_박창현/README.md</a:t>
+            </a:r>
+          </a:p>
+          <a:p xmlns:a="http://schemas.openxmlformats.org/drawingml/2006/main">
+            <a:r>
+              <a:t>- https://github.com/pkchanghyun-pixel/hub/blob/N091_박창현/docs/DEMO_DAY_CORE_FLOW.md</a:t>
+            </a:r>
+          </a:p>
+          <a:p xmlns:a="http://schemas.openxmlformats.org/drawingml/2006/main">
+            <a:r>
               <a:t>- C:/Users/pkcha/OneDrive/문서/AI agent challenge/hub-upload-worktree/backend/routes/ingredients.js</a:t>
             </a:r>
           </a:p>
@@ -458,16 +473,6 @@
           <a:p xmlns:a="http://schemas.openxmlformats.org/drawingml/2006/main">
             <a:r>
               <a:t>- C:/Users/pkcha/OneDrive/문서/AI agent challenge/hub-upload-worktree/backend/services/geminiRecommendations.js</a:t>
-            </a:r>
-          </a:p>
-          <a:p xmlns:a="http://schemas.openxmlformats.org/drawingml/2006/main">
-            <a:r>
-              <a:t>- C:/Users/pkcha/OneDrive/문서/AI agent challenge/hub-upload-worktree/frontend/src/services/ingredients.js</a:t>
-            </a:r>
-          </a:p>
-          <a:p xmlns:a="http://schemas.openxmlformats.org/drawingml/2006/main">
-            <a:r>
-              <a:t>- C:/Users/pkcha/OneDrive/문서/AI agent challenge/hub-upload-worktree/frontend/src/services/recommendations.js</a:t>
             </a:r>
           </a:p>
           <a:p xmlns:a="http://schemas.openxmlformats.org/drawingml/2006/main">
@@ -540,7 +545,7 @@
   </p:cSld>
   <p:clrMap bg1="lt1" tx1="dk1" bg2="lt2" tx2="dk2" accent1="accent1" accent2="accent2" accent3="accent3" accent4="accent4" accent5="accent5" accent6="accent6" hlink="hlink" folHlink="folHlink"/>
   <p:sldLayoutIdLst>
-    <p:sldLayoutId xmlns:r="http://schemas.openxmlformats.org/officeDocument/2006/relationships" id="2147483649" r:id="R6a5a90dd84b44331"/>
+    <p:sldLayoutId xmlns:r="http://schemas.openxmlformats.org/officeDocument/2006/relationships" id="2147483649" r:id="R9957232c59244ea9"/>
   </p:sldLayoutIdLst>
   <p:txStyles>
     <p:titleStyle>
@@ -1306,7 +1311,7 @@
                   <a:srgbClr val="FFFFFF"/>
                 </a:solidFill>
               </a:rPr>
-              <a:t>냉장고 재료 기반 1인분 추천 서비스</a:t>
+              <a:t>냉장고 속 재료로 지금 만들 수 있는 한 끼를 추천하는 웹 서비스</a:t>
             </a:r>
           </a:p>
         </p:txBody>
@@ -1519,7 +1524,7 @@
         <p:spPr>
           <a:xfrm xmlns:a="http://schemas.openxmlformats.org/drawingml/2006/main">
             <a:off x="609600" y="2800350"/>
-            <a:ext cx="7239000" cy="419100"/>
+            <a:ext cx="6667500" cy="419100"/>
           </a:xfrm>
           <a:prstGeom xmlns:a="http://schemas.openxmlformats.org/drawingml/2006/main" prst="rect">
             <a:avLst/>
@@ -1535,6 +1540,7 @@
           <a:lstStyle xmlns:a="http://schemas.openxmlformats.org/drawingml/2006/main"/>
           <a:p xmlns:a="http://schemas.openxmlformats.org/drawingml/2006/main">
             <a:pPr algn="l">
+              <a:buNone/>
               <a:defRPr sz="2550" b="1">
                 <a:solidFill>
                   <a:srgbClr val="1A1C19"/>
@@ -1547,7 +1553,7 @@
                   <a:srgbClr val="1A1C19"/>
                 </a:solidFill>
               </a:rPr>
-              <a:t>재료는 있는데, 오늘 뭐 먹지?</a:t>
+              <a:t>메뉴 결정은 빠르게, 남은 재료는 알뜰하게</a:t>
             </a:r>
           </a:p>
         </p:txBody>
@@ -1569,7 +1575,7 @@
         <p:spPr>
           <a:xfrm xmlns:a="http://schemas.openxmlformats.org/drawingml/2006/main">
             <a:off x="609600" y="3267075"/>
-            <a:ext cx="7905750" cy="285750"/>
+            <a:ext cx="6667500" cy="361950"/>
           </a:xfrm>
           <a:prstGeom xmlns:a="http://schemas.openxmlformats.org/drawingml/2006/main" prst="rect">
             <a:avLst/>
@@ -1585,6 +1591,7 @@
           <a:lstStyle xmlns:a="http://schemas.openxmlformats.org/drawingml/2006/main"/>
           <a:p xmlns:a="http://schemas.openxmlformats.org/drawingml/2006/main">
             <a:pPr algn="l">
+              <a:buNone/>
               <a:defRPr sz="1350" b="0">
                 <a:solidFill>
                   <a:srgbClr val="6D6A66"/>
@@ -1597,7 +1604,7 @@
                   <a:srgbClr val="6D6A66"/>
                 </a:solidFill>
               </a:rPr>
-              <a:t>냉장고 속 보유 재료와 소비기한을 확인해 지금 만들 수 있는 1인분 메뉴로 연결합니다.</a:t>
+              <a:t>조리 시간·영양 균형·부족 재료를 함께 보여주고, 초보자도 따라 할 수 있는 1인분 레시피로 연결합니다.</a:t>
             </a:r>
           </a:p>
         </p:txBody>
@@ -1651,8 +1658,8 @@
         </p:nvSpPr>
         <p:spPr>
           <a:xfrm xmlns:a="http://schemas.openxmlformats.org/drawingml/2006/main">
-            <a:off x="8477250" y="3038475"/>
-            <a:ext cx="1495425" cy="238125"/>
+            <a:off x="8477250" y="2914650"/>
+            <a:ext cx="1495425" cy="457200"/>
           </a:xfrm>
           <a:prstGeom xmlns:a="http://schemas.openxmlformats.org/drawingml/2006/main" prst="rect">
             <a:avLst/>
@@ -1668,6 +1675,7 @@
           <a:lstStyle xmlns:a="http://schemas.openxmlformats.org/drawingml/2006/main"/>
           <a:p xmlns:a="http://schemas.openxmlformats.org/drawingml/2006/main">
             <a:pPr algn="ctr">
+              <a:buNone/>
               <a:defRPr sz="1125" b="1">
                 <a:solidFill>
                   <a:srgbClr val="006D36"/>
@@ -1680,7 +1688,9 @@
                   <a:srgbClr val="006D36"/>
                 </a:solidFill>
               </a:rPr>
-              <a:t>확인 → 추천 → 요리 → 반영</a:t>
+              <a:t>기획 의도
+메뉴 고민·재료 낭비 ↓
+간단한 집밥 ↑</a:t>
             </a:r>
           </a:p>
         </p:txBody>
@@ -2096,6 +2106,7 @@
           <a:lstStyle xmlns:a="http://schemas.openxmlformats.org/drawingml/2006/main"/>
           <a:p xmlns:a="http://schemas.openxmlformats.org/drawingml/2006/main">
             <a:pPr algn="ctr">
+              <a:buNone/>
               <a:defRPr sz="1650" b="1">
                 <a:solidFill>
                   <a:srgbClr val="FF7E47"/>
@@ -2146,6 +2157,7 @@
           <a:lstStyle xmlns:a="http://schemas.openxmlformats.org/drawingml/2006/main"/>
           <a:p xmlns:a="http://schemas.openxmlformats.org/drawingml/2006/main">
             <a:pPr algn="l">
+              <a:buNone/>
               <a:defRPr sz="1875" b="1">
                 <a:solidFill>
                   <a:srgbClr val="1A1C19"/>
@@ -2196,6 +2208,7 @@
           <a:lstStyle xmlns:a="http://schemas.openxmlformats.org/drawingml/2006/main"/>
           <a:p xmlns:a="http://schemas.openxmlformats.org/drawingml/2006/main">
             <a:pPr algn="l">
+              <a:buNone/>
               <a:defRPr sz="1125" b="0">
                 <a:solidFill>
                   <a:srgbClr val="6D6A66"/>
@@ -2314,6 +2327,7 @@
           <a:lstStyle xmlns:a="http://schemas.openxmlformats.org/drawingml/2006/main"/>
           <a:p xmlns:a="http://schemas.openxmlformats.org/drawingml/2006/main">
             <a:pPr algn="l">
+              <a:buNone/>
               <a:defRPr sz="975" b="1">
                 <a:solidFill>
                   <a:srgbClr val="FF7E47"/>
@@ -2364,6 +2378,7 @@
           <a:lstStyle xmlns:a="http://schemas.openxmlformats.org/drawingml/2006/main"/>
           <a:p xmlns:a="http://schemas.openxmlformats.org/drawingml/2006/main">
             <a:pPr algn="ctr">
+              <a:buNone/>
               <a:defRPr sz="1350" b="1">
                 <a:solidFill>
                   <a:srgbClr val="B7AEA6"/>
@@ -2414,6 +2429,7 @@
           <a:lstStyle xmlns:a="http://schemas.openxmlformats.org/drawingml/2006/main"/>
           <a:p xmlns:a="http://schemas.openxmlformats.org/drawingml/2006/main">
             <a:pPr algn="ctr">
+              <a:buNone/>
               <a:defRPr sz="900" b="0">
                 <a:solidFill>
                   <a:srgbClr val="A79E96"/>
@@ -2464,6 +2480,7 @@
           <a:lstStyle xmlns:a="http://schemas.openxmlformats.org/drawingml/2006/main"/>
           <a:p xmlns:a="http://schemas.openxmlformats.org/drawingml/2006/main">
             <a:pPr algn="l">
+              <a:buNone/>
               <a:defRPr sz="1050" b="1">
                 <a:solidFill>
                   <a:srgbClr val="FF7E47"/>
@@ -2514,6 +2531,7 @@
           <a:lstStyle xmlns:a="http://schemas.openxmlformats.org/drawingml/2006/main"/>
           <a:p xmlns:a="http://schemas.openxmlformats.org/drawingml/2006/main">
             <a:pPr algn="l">
+              <a:buNone/>
               <a:defRPr sz="1050" b="0">
                 <a:solidFill>
                   <a:srgbClr val="1A1C19"/>
@@ -2531,6 +2549,7 @@
           </a:p>
           <a:p xmlns:a="http://schemas.openxmlformats.org/drawingml/2006/main">
             <a:pPr algn="l">
+              <a:buNone/>
               <a:defRPr sz="1050" b="0">
                 <a:solidFill>
                   <a:srgbClr val="1A1C19"/>
@@ -2548,6 +2567,7 @@
           </a:p>
           <a:p xmlns:a="http://schemas.openxmlformats.org/drawingml/2006/main">
             <a:pPr algn="l">
+              <a:buNone/>
               <a:defRPr sz="1050" b="0">
                 <a:solidFill>
                   <a:srgbClr val="1A1C19"/>
@@ -2697,6 +2717,7 @@
           <a:lstStyle xmlns:a="http://schemas.openxmlformats.org/drawingml/2006/main"/>
           <a:p xmlns:a="http://schemas.openxmlformats.org/drawingml/2006/main">
             <a:pPr algn="ctr">
+              <a:buNone/>
               <a:defRPr sz="1650" b="1">
                 <a:solidFill>
                   <a:srgbClr val="006D36"/>
@@ -2747,6 +2768,7 @@
           <a:lstStyle xmlns:a="http://schemas.openxmlformats.org/drawingml/2006/main"/>
           <a:p xmlns:a="http://schemas.openxmlformats.org/drawingml/2006/main">
             <a:pPr algn="l">
+              <a:buNone/>
               <a:defRPr sz="1875" b="1">
                 <a:solidFill>
                   <a:srgbClr val="1A1C19"/>
@@ -2797,6 +2819,7 @@
           <a:lstStyle xmlns:a="http://schemas.openxmlformats.org/drawingml/2006/main"/>
           <a:p xmlns:a="http://schemas.openxmlformats.org/drawingml/2006/main">
             <a:pPr algn="l">
+              <a:buNone/>
               <a:defRPr sz="1125" b="0">
                 <a:solidFill>
                   <a:srgbClr val="6D6A66"/>
@@ -2915,6 +2938,7 @@
           <a:lstStyle xmlns:a="http://schemas.openxmlformats.org/drawingml/2006/main"/>
           <a:p xmlns:a="http://schemas.openxmlformats.org/drawingml/2006/main">
             <a:pPr algn="l">
+              <a:buNone/>
               <a:defRPr sz="975" b="1">
                 <a:solidFill>
                   <a:srgbClr val="006D36"/>
@@ -2965,6 +2989,7 @@
           <a:lstStyle xmlns:a="http://schemas.openxmlformats.org/drawingml/2006/main"/>
           <a:p xmlns:a="http://schemas.openxmlformats.org/drawingml/2006/main">
             <a:pPr algn="ctr">
+              <a:buNone/>
               <a:defRPr sz="1350" b="1">
                 <a:solidFill>
                   <a:srgbClr val="B7AEA6"/>
@@ -3015,6 +3040,7 @@
           <a:lstStyle xmlns:a="http://schemas.openxmlformats.org/drawingml/2006/main"/>
           <a:p xmlns:a="http://schemas.openxmlformats.org/drawingml/2006/main">
             <a:pPr algn="ctr">
+              <a:buNone/>
               <a:defRPr sz="900" b="0">
                 <a:solidFill>
                   <a:srgbClr val="A79E96"/>
@@ -3065,6 +3091,7 @@
           <a:lstStyle xmlns:a="http://schemas.openxmlformats.org/drawingml/2006/main"/>
           <a:p xmlns:a="http://schemas.openxmlformats.org/drawingml/2006/main">
             <a:pPr algn="l">
+              <a:buNone/>
               <a:defRPr sz="1050" b="1">
                 <a:solidFill>
                   <a:srgbClr val="006D36"/>
@@ -3115,6 +3142,7 @@
           <a:lstStyle xmlns:a="http://schemas.openxmlformats.org/drawingml/2006/main"/>
           <a:p xmlns:a="http://schemas.openxmlformats.org/drawingml/2006/main">
             <a:pPr algn="l">
+              <a:buNone/>
               <a:defRPr sz="1050" b="0">
                 <a:solidFill>
                   <a:srgbClr val="1A1C19"/>
@@ -3132,6 +3160,7 @@
           </a:p>
           <a:p xmlns:a="http://schemas.openxmlformats.org/drawingml/2006/main">
             <a:pPr algn="l">
+              <a:buNone/>
               <a:defRPr sz="1050" b="0">
                 <a:solidFill>
                   <a:srgbClr val="1A1C19"/>
@@ -3149,6 +3178,7 @@
           </a:p>
           <a:p xmlns:a="http://schemas.openxmlformats.org/drawingml/2006/main">
             <a:pPr algn="l">
+              <a:buNone/>
               <a:defRPr sz="1050" b="0">
                 <a:solidFill>
                   <a:srgbClr val="1A1C19"/>
@@ -3298,6 +3328,7 @@
           <a:lstStyle xmlns:a="http://schemas.openxmlformats.org/drawingml/2006/main"/>
           <a:p xmlns:a="http://schemas.openxmlformats.org/drawingml/2006/main">
             <a:pPr algn="ctr">
+              <a:buNone/>
               <a:defRPr sz="1650" b="1">
                 <a:solidFill>
                   <a:srgbClr val="006D36"/>
@@ -3348,6 +3379,7 @@
           <a:lstStyle xmlns:a="http://schemas.openxmlformats.org/drawingml/2006/main"/>
           <a:p xmlns:a="http://schemas.openxmlformats.org/drawingml/2006/main">
             <a:pPr algn="l">
+              <a:buNone/>
               <a:defRPr sz="1875" b="1">
                 <a:solidFill>
                   <a:srgbClr val="1A1C19"/>
@@ -3398,6 +3430,7 @@
           <a:lstStyle xmlns:a="http://schemas.openxmlformats.org/drawingml/2006/main"/>
           <a:p xmlns:a="http://schemas.openxmlformats.org/drawingml/2006/main">
             <a:pPr algn="l">
+              <a:buNone/>
               <a:defRPr sz="1125" b="0">
                 <a:solidFill>
                   <a:srgbClr val="6D6A66"/>
@@ -3516,6 +3549,7 @@
           <a:lstStyle xmlns:a="http://schemas.openxmlformats.org/drawingml/2006/main"/>
           <a:p xmlns:a="http://schemas.openxmlformats.org/drawingml/2006/main">
             <a:pPr algn="l">
+              <a:buNone/>
               <a:defRPr sz="975" b="1">
                 <a:solidFill>
                   <a:srgbClr val="006D36"/>
@@ -3566,6 +3600,7 @@
           <a:lstStyle xmlns:a="http://schemas.openxmlformats.org/drawingml/2006/main"/>
           <a:p xmlns:a="http://schemas.openxmlformats.org/drawingml/2006/main">
             <a:pPr algn="ctr">
+              <a:buNone/>
               <a:defRPr sz="1350" b="1">
                 <a:solidFill>
                   <a:srgbClr val="B7AEA6"/>
@@ -3616,6 +3651,7 @@
           <a:lstStyle xmlns:a="http://schemas.openxmlformats.org/drawingml/2006/main"/>
           <a:p xmlns:a="http://schemas.openxmlformats.org/drawingml/2006/main">
             <a:pPr algn="ctr">
+              <a:buNone/>
               <a:defRPr sz="900" b="0">
                 <a:solidFill>
                   <a:srgbClr val="A79E96"/>
@@ -3666,6 +3702,7 @@
           <a:lstStyle xmlns:a="http://schemas.openxmlformats.org/drawingml/2006/main"/>
           <a:p xmlns:a="http://schemas.openxmlformats.org/drawingml/2006/main">
             <a:pPr algn="l">
+              <a:buNone/>
               <a:defRPr sz="1050" b="1">
                 <a:solidFill>
                   <a:srgbClr val="006D36"/>
@@ -3716,6 +3753,7 @@
           <a:lstStyle xmlns:a="http://schemas.openxmlformats.org/drawingml/2006/main"/>
           <a:p xmlns:a="http://schemas.openxmlformats.org/drawingml/2006/main">
             <a:pPr algn="l">
+              <a:buNone/>
               <a:defRPr sz="1050" b="0">
                 <a:solidFill>
                   <a:srgbClr val="1A1C19"/>
@@ -3733,6 +3771,7 @@
           </a:p>
           <a:p xmlns:a="http://schemas.openxmlformats.org/drawingml/2006/main">
             <a:pPr algn="l">
+              <a:buNone/>
               <a:defRPr sz="1050" b="0">
                 <a:solidFill>
                   <a:srgbClr val="1A1C19"/>
@@ -3750,6 +3789,7 @@
           </a:p>
           <a:p xmlns:a="http://schemas.openxmlformats.org/drawingml/2006/main">
             <a:pPr algn="l">
+              <a:buNone/>
               <a:defRPr sz="1050" b="0">
                 <a:solidFill>
                   <a:srgbClr val="1A1C19"/>
@@ -3899,6 +3939,7 @@
           <a:lstStyle xmlns:a="http://schemas.openxmlformats.org/drawingml/2006/main"/>
           <a:p xmlns:a="http://schemas.openxmlformats.org/drawingml/2006/main">
             <a:pPr algn="ctr">
+              <a:buNone/>
               <a:defRPr sz="1650" b="1">
                 <a:solidFill>
                   <a:srgbClr val="FF7E47"/>
@@ -3949,6 +3990,7 @@
           <a:lstStyle xmlns:a="http://schemas.openxmlformats.org/drawingml/2006/main"/>
           <a:p xmlns:a="http://schemas.openxmlformats.org/drawingml/2006/main">
             <a:pPr algn="l">
+              <a:buNone/>
               <a:defRPr sz="1875" b="1">
                 <a:solidFill>
                   <a:srgbClr val="1A1C19"/>
@@ -3999,6 +4041,7 @@
           <a:lstStyle xmlns:a="http://schemas.openxmlformats.org/drawingml/2006/main"/>
           <a:p xmlns:a="http://schemas.openxmlformats.org/drawingml/2006/main">
             <a:pPr algn="l">
+              <a:buNone/>
               <a:defRPr sz="1125" b="0">
                 <a:solidFill>
                   <a:srgbClr val="6D6A66"/>
@@ -4117,6 +4160,7 @@
           <a:lstStyle xmlns:a="http://schemas.openxmlformats.org/drawingml/2006/main"/>
           <a:p xmlns:a="http://schemas.openxmlformats.org/drawingml/2006/main">
             <a:pPr algn="l">
+              <a:buNone/>
               <a:defRPr sz="975" b="1">
                 <a:solidFill>
                   <a:srgbClr val="FF7E47"/>
@@ -4167,6 +4211,7 @@
           <a:lstStyle xmlns:a="http://schemas.openxmlformats.org/drawingml/2006/main"/>
           <a:p xmlns:a="http://schemas.openxmlformats.org/drawingml/2006/main">
             <a:pPr algn="ctr">
+              <a:buNone/>
               <a:defRPr sz="1350" b="1">
                 <a:solidFill>
                   <a:srgbClr val="B7AEA6"/>
@@ -4217,6 +4262,7 @@
           <a:lstStyle xmlns:a="http://schemas.openxmlformats.org/drawingml/2006/main"/>
           <a:p xmlns:a="http://schemas.openxmlformats.org/drawingml/2006/main">
             <a:pPr algn="ctr">
+              <a:buNone/>
               <a:defRPr sz="900" b="0">
                 <a:solidFill>
                   <a:srgbClr val="A79E96"/>
@@ -4267,6 +4313,7 @@
           <a:lstStyle xmlns:a="http://schemas.openxmlformats.org/drawingml/2006/main"/>
           <a:p xmlns:a="http://schemas.openxmlformats.org/drawingml/2006/main">
             <a:pPr algn="l">
+              <a:buNone/>
               <a:defRPr sz="1050" b="1">
                 <a:solidFill>
                   <a:srgbClr val="FF7E47"/>
@@ -4317,6 +4364,7 @@
           <a:lstStyle xmlns:a="http://schemas.openxmlformats.org/drawingml/2006/main"/>
           <a:p xmlns:a="http://schemas.openxmlformats.org/drawingml/2006/main">
             <a:pPr algn="l">
+              <a:buNone/>
               <a:defRPr sz="1050" b="0">
                 <a:solidFill>
                   <a:srgbClr val="1A1C19"/>
@@ -4334,6 +4382,7 @@
           </a:p>
           <a:p xmlns:a="http://schemas.openxmlformats.org/drawingml/2006/main">
             <a:pPr algn="l">
+              <a:buNone/>
               <a:defRPr sz="1050" b="0">
                 <a:solidFill>
                   <a:srgbClr val="1A1C19"/>
@@ -4351,6 +4400,7 @@
           </a:p>
           <a:p xmlns:a="http://schemas.openxmlformats.org/drawingml/2006/main">
             <a:pPr algn="l">
+              <a:buNone/>
               <a:defRPr sz="1050" b="0">
                 <a:solidFill>
                   <a:srgbClr val="1A1C19"/>
@@ -4434,6 +4484,7 @@
           <a:lstStyle xmlns:a="http://schemas.openxmlformats.org/drawingml/2006/main"/>
           <a:p xmlns:a="http://schemas.openxmlformats.org/drawingml/2006/main">
             <a:pPr algn="ctr">
+              <a:buNone/>
               <a:defRPr sz="1350" b="1">
                 <a:solidFill>
                   <a:srgbClr val="006D36"/>

</xml_diff>